<commit_message>
Afegir documentacio final, USB i presentacio del projecte
</commit_message>
<xml_diff>
--- a/docs/Presentacio_PersonalBet.pptx
+++ b/docs/Presentacio_PersonalBet.pptx
@@ -5,18 +5,18 @@
     <p:sldMasterId id="2147483648" r:id="rId1"/>
   </p:sldMasterIdLst>
   <p:sldIdLst>
-    <p:sldId id="256" r:id="rId7"/>
-    <p:sldId id="257" r:id="rId8"/>
-    <p:sldId id="258" r:id="rId9"/>
-    <p:sldId id="259" r:id="rId10"/>
-    <p:sldId id="260" r:id="rId11"/>
-    <p:sldId id="261" r:id="rId12"/>
-    <p:sldId id="262" r:id="rId13"/>
-    <p:sldId id="263" r:id="rId14"/>
-    <p:sldId id="264" r:id="rId15"/>
-    <p:sldId id="265" r:id="rId16"/>
-    <p:sldId id="266" r:id="rId17"/>
-    <p:sldId id="267" r:id="rId18"/>
+    <p:sldId id="256" r:id="rId2"/>
+    <p:sldId id="257" r:id="rId3"/>
+    <p:sldId id="258" r:id="rId4"/>
+    <p:sldId id="259" r:id="rId5"/>
+    <p:sldId id="260" r:id="rId6"/>
+    <p:sldId id="261" r:id="rId7"/>
+    <p:sldId id="262" r:id="rId8"/>
+    <p:sldId id="263" r:id="rId9"/>
+    <p:sldId id="264" r:id="rId10"/>
+    <p:sldId id="265" r:id="rId11"/>
+    <p:sldId id="266" r:id="rId12"/>
+    <p:sldId id="267" r:id="rId13"/>
   </p:sldIdLst>
   <p:sldSz cx="9144000" cy="6858000" type="screen4x3"/>
   <p:notesSz cx="6858000" cy="9144000"/>
@@ -115,6 +115,22 @@
       </a:defRPr>
     </a:lvl9pPr>
   </p:defaultTextStyle>
+  <p:extLst>
+    <p:ext uri="{EFAFB233-063F-42B5-8137-9DF3F51BA10A}">
+      <p15:sldGuideLst xmlns:p15="http://schemas.microsoft.com/office/powerpoint/2012/main">
+        <p15:guide id="1" orient="horz" pos="2160">
+          <p15:clr>
+            <a:srgbClr val="A4A3A4"/>
+          </p15:clr>
+        </p15:guide>
+        <p15:guide id="2" pos="2880">
+          <p15:clr>
+            <a:srgbClr val="A4A3A4"/>
+          </p15:clr>
+        </p15:guide>
+      </p15:sldGuideLst>
+    </p:ext>
+  </p:extLst>
 </p:presentation>
 </file>
 
@@ -156,10 +172,9 @@
           <a:lstStyle/>
           <a:p>
             <a:r>
-              <a:rPr lang="en-US" smtClean="0"/>
+              <a:rPr lang="en-US"/>
               <a:t>Click to edit Master title style</a:t>
             </a:r>
-            <a:endParaRPr lang="en-US"/>
           </a:p>
         </p:txBody>
       </p:sp>
@@ -275,10 +290,9 @@
           </a:lstStyle>
           <a:p>
             <a:r>
-              <a:rPr lang="en-US" smtClean="0"/>
+              <a:rPr lang="en-US"/>
               <a:t>Click to edit Master subtitle style</a:t>
             </a:r>
-            <a:endParaRPr lang="en-US"/>
           </a:p>
         </p:txBody>
       </p:sp>
@@ -299,7 +313,7 @@
           <a:p>
             <a:fld id="{5BCAD085-E8A6-8845-BD4E-CB4CCA059FC4}" type="datetimeFigureOut">
               <a:rPr lang="en-US" smtClean="0"/>
-              <a:t>1/27/13</a:t>
+              <a:t>6/7/2026</a:t>
             </a:fld>
             <a:endParaRPr lang="en-US"/>
           </a:p>
@@ -341,7 +355,7 @@
           <a:p>
             <a:fld id="{C1FF6DA9-008F-8B48-92A6-B652298478BF}" type="slidenum">
               <a:rPr lang="en-US" smtClean="0"/>
-              <a:t>‹#›</a:t>
+              <a:t>‹Nº›</a:t>
             </a:fld>
             <a:endParaRPr lang="en-US"/>
           </a:p>
@@ -393,10 +407,9 @@
           <a:lstStyle/>
           <a:p>
             <a:r>
-              <a:rPr lang="en-US" smtClean="0"/>
+              <a:rPr lang="en-US"/>
               <a:t>Click to edit Master title style</a:t>
             </a:r>
-            <a:endParaRPr lang="en-US"/>
           </a:p>
         </p:txBody>
       </p:sp>
@@ -417,38 +430,37 @@
           <a:p>
             <a:pPr lvl="0"/>
             <a:r>
-              <a:rPr lang="en-US" smtClean="0"/>
+              <a:rPr lang="en-US"/>
               <a:t>Click to edit Master text styles</a:t>
             </a:r>
           </a:p>
           <a:p>
             <a:pPr lvl="1"/>
             <a:r>
-              <a:rPr lang="en-US" smtClean="0"/>
+              <a:rPr lang="en-US"/>
               <a:t>Second level</a:t>
             </a:r>
           </a:p>
           <a:p>
             <a:pPr lvl="2"/>
             <a:r>
-              <a:rPr lang="en-US" smtClean="0"/>
+              <a:rPr lang="en-US"/>
               <a:t>Third level</a:t>
             </a:r>
           </a:p>
           <a:p>
             <a:pPr lvl="3"/>
             <a:r>
-              <a:rPr lang="en-US" smtClean="0"/>
+              <a:rPr lang="en-US"/>
               <a:t>Fourth level</a:t>
             </a:r>
           </a:p>
           <a:p>
             <a:pPr lvl="4"/>
             <a:r>
-              <a:rPr lang="en-US" smtClean="0"/>
+              <a:rPr lang="en-US"/>
               <a:t>Fifth level</a:t>
             </a:r>
-            <a:endParaRPr lang="en-US"/>
           </a:p>
         </p:txBody>
       </p:sp>
@@ -469,7 +481,7 @@
           <a:p>
             <a:fld id="{5BCAD085-E8A6-8845-BD4E-CB4CCA059FC4}" type="datetimeFigureOut">
               <a:rPr lang="en-US" smtClean="0"/>
-              <a:t>1/27/13</a:t>
+              <a:t>6/7/2026</a:t>
             </a:fld>
             <a:endParaRPr lang="en-US"/>
           </a:p>
@@ -511,7 +523,7 @@
           <a:p>
             <a:fld id="{C1FF6DA9-008F-8B48-92A6-B652298478BF}" type="slidenum">
               <a:rPr lang="en-US" smtClean="0"/>
-              <a:t>‹#›</a:t>
+              <a:t>‹Nº›</a:t>
             </a:fld>
             <a:endParaRPr lang="en-US"/>
           </a:p>
@@ -568,10 +580,9 @@
           <a:lstStyle/>
           <a:p>
             <a:r>
-              <a:rPr lang="en-US" smtClean="0"/>
+              <a:rPr lang="en-US"/>
               <a:t>Click to edit Master title style</a:t>
             </a:r>
-            <a:endParaRPr lang="en-US"/>
           </a:p>
         </p:txBody>
       </p:sp>
@@ -597,38 +608,37 @@
           <a:p>
             <a:pPr lvl="0"/>
             <a:r>
-              <a:rPr lang="en-US" smtClean="0"/>
+              <a:rPr lang="en-US"/>
               <a:t>Click to edit Master text styles</a:t>
             </a:r>
           </a:p>
           <a:p>
             <a:pPr lvl="1"/>
             <a:r>
-              <a:rPr lang="en-US" smtClean="0"/>
+              <a:rPr lang="en-US"/>
               <a:t>Second level</a:t>
             </a:r>
           </a:p>
           <a:p>
             <a:pPr lvl="2"/>
             <a:r>
-              <a:rPr lang="en-US" smtClean="0"/>
+              <a:rPr lang="en-US"/>
               <a:t>Third level</a:t>
             </a:r>
           </a:p>
           <a:p>
             <a:pPr lvl="3"/>
             <a:r>
-              <a:rPr lang="en-US" smtClean="0"/>
+              <a:rPr lang="en-US"/>
               <a:t>Fourth level</a:t>
             </a:r>
           </a:p>
           <a:p>
             <a:pPr lvl="4"/>
             <a:r>
-              <a:rPr lang="en-US" smtClean="0"/>
+              <a:rPr lang="en-US"/>
               <a:t>Fifth level</a:t>
             </a:r>
-            <a:endParaRPr lang="en-US"/>
           </a:p>
         </p:txBody>
       </p:sp>
@@ -649,7 +659,7 @@
           <a:p>
             <a:fld id="{5BCAD085-E8A6-8845-BD4E-CB4CCA059FC4}" type="datetimeFigureOut">
               <a:rPr lang="en-US" smtClean="0"/>
-              <a:t>1/27/13</a:t>
+              <a:t>6/7/2026</a:t>
             </a:fld>
             <a:endParaRPr lang="en-US"/>
           </a:p>
@@ -691,7 +701,7 @@
           <a:p>
             <a:fld id="{C1FF6DA9-008F-8B48-92A6-B652298478BF}" type="slidenum">
               <a:rPr lang="en-US" smtClean="0"/>
-              <a:t>‹#›</a:t>
+              <a:t>‹Nº›</a:t>
             </a:fld>
             <a:endParaRPr lang="en-US"/>
           </a:p>
@@ -743,10 +753,9 @@
           <a:lstStyle/>
           <a:p>
             <a:r>
-              <a:rPr lang="en-US" smtClean="0"/>
+              <a:rPr lang="en-US"/>
               <a:t>Click to edit Master title style</a:t>
             </a:r>
-            <a:endParaRPr lang="en-US"/>
           </a:p>
         </p:txBody>
       </p:sp>
@@ -767,38 +776,37 @@
           <a:p>
             <a:pPr lvl="0"/>
             <a:r>
-              <a:rPr lang="en-US" smtClean="0"/>
+              <a:rPr lang="en-US"/>
               <a:t>Click to edit Master text styles</a:t>
             </a:r>
           </a:p>
           <a:p>
             <a:pPr lvl="1"/>
             <a:r>
-              <a:rPr lang="en-US" smtClean="0"/>
+              <a:rPr lang="en-US"/>
               <a:t>Second level</a:t>
             </a:r>
           </a:p>
           <a:p>
             <a:pPr lvl="2"/>
             <a:r>
-              <a:rPr lang="en-US" smtClean="0"/>
+              <a:rPr lang="en-US"/>
               <a:t>Third level</a:t>
             </a:r>
           </a:p>
           <a:p>
             <a:pPr lvl="3"/>
             <a:r>
-              <a:rPr lang="en-US" smtClean="0"/>
+              <a:rPr lang="en-US"/>
               <a:t>Fourth level</a:t>
             </a:r>
           </a:p>
           <a:p>
             <a:pPr lvl="4"/>
             <a:r>
-              <a:rPr lang="en-US" smtClean="0"/>
+              <a:rPr lang="en-US"/>
               <a:t>Fifth level</a:t>
             </a:r>
-            <a:endParaRPr lang="en-US"/>
           </a:p>
         </p:txBody>
       </p:sp>
@@ -819,7 +827,7 @@
           <a:p>
             <a:fld id="{5BCAD085-E8A6-8845-BD4E-CB4CCA059FC4}" type="datetimeFigureOut">
               <a:rPr lang="en-US" smtClean="0"/>
-              <a:t>1/27/13</a:t>
+              <a:t>6/7/2026</a:t>
             </a:fld>
             <a:endParaRPr lang="en-US"/>
           </a:p>
@@ -861,7 +869,7 @@
           <a:p>
             <a:fld id="{C1FF6DA9-008F-8B48-92A6-B652298478BF}" type="slidenum">
               <a:rPr lang="en-US" smtClean="0"/>
-              <a:t>‹#›</a:t>
+              <a:t>‹Nº›</a:t>
             </a:fld>
             <a:endParaRPr lang="en-US"/>
           </a:p>
@@ -922,10 +930,9 @@
           </a:lstStyle>
           <a:p>
             <a:r>
-              <a:rPr lang="en-US" smtClean="0"/>
+              <a:rPr lang="en-US"/>
               <a:t>Click to edit Master title style</a:t>
             </a:r>
-            <a:endParaRPr lang="en-US"/>
           </a:p>
         </p:txBody>
       </p:sp>
@@ -1042,7 +1049,7 @@
           <a:p>
             <a:pPr lvl="0"/>
             <a:r>
-              <a:rPr lang="en-US" smtClean="0"/>
+              <a:rPr lang="en-US"/>
               <a:t>Click to edit Master text styles</a:t>
             </a:r>
           </a:p>
@@ -1065,7 +1072,7 @@
           <a:p>
             <a:fld id="{5BCAD085-E8A6-8845-BD4E-CB4CCA059FC4}" type="datetimeFigureOut">
               <a:rPr lang="en-US" smtClean="0"/>
-              <a:t>1/27/13</a:t>
+              <a:t>6/7/2026</a:t>
             </a:fld>
             <a:endParaRPr lang="en-US"/>
           </a:p>
@@ -1107,7 +1114,7 @@
           <a:p>
             <a:fld id="{C1FF6DA9-008F-8B48-92A6-B652298478BF}" type="slidenum">
               <a:rPr lang="en-US" smtClean="0"/>
-              <a:t>‹#›</a:t>
+              <a:t>‹Nº›</a:t>
             </a:fld>
             <a:endParaRPr lang="en-US"/>
           </a:p>
@@ -1159,10 +1166,9 @@
           <a:lstStyle/>
           <a:p>
             <a:r>
-              <a:rPr lang="en-US" smtClean="0"/>
+              <a:rPr lang="en-US"/>
               <a:t>Click to edit Master title style</a:t>
             </a:r>
-            <a:endParaRPr lang="en-US"/>
           </a:p>
         </p:txBody>
       </p:sp>
@@ -1216,38 +1222,37 @@
           <a:p>
             <a:pPr lvl="0"/>
             <a:r>
-              <a:rPr lang="en-US" smtClean="0"/>
+              <a:rPr lang="en-US"/>
               <a:t>Click to edit Master text styles</a:t>
             </a:r>
           </a:p>
           <a:p>
             <a:pPr lvl="1"/>
             <a:r>
-              <a:rPr lang="en-US" smtClean="0"/>
+              <a:rPr lang="en-US"/>
               <a:t>Second level</a:t>
             </a:r>
           </a:p>
           <a:p>
             <a:pPr lvl="2"/>
             <a:r>
-              <a:rPr lang="en-US" smtClean="0"/>
+              <a:rPr lang="en-US"/>
               <a:t>Third level</a:t>
             </a:r>
           </a:p>
           <a:p>
             <a:pPr lvl="3"/>
             <a:r>
-              <a:rPr lang="en-US" smtClean="0"/>
+              <a:rPr lang="en-US"/>
               <a:t>Fourth level</a:t>
             </a:r>
           </a:p>
           <a:p>
             <a:pPr lvl="4"/>
             <a:r>
-              <a:rPr lang="en-US" smtClean="0"/>
+              <a:rPr lang="en-US"/>
               <a:t>Fifth level</a:t>
             </a:r>
-            <a:endParaRPr lang="en-US"/>
           </a:p>
         </p:txBody>
       </p:sp>
@@ -1301,38 +1306,37 @@
           <a:p>
             <a:pPr lvl="0"/>
             <a:r>
-              <a:rPr lang="en-US" smtClean="0"/>
+              <a:rPr lang="en-US"/>
               <a:t>Click to edit Master text styles</a:t>
             </a:r>
           </a:p>
           <a:p>
             <a:pPr lvl="1"/>
             <a:r>
-              <a:rPr lang="en-US" smtClean="0"/>
+              <a:rPr lang="en-US"/>
               <a:t>Second level</a:t>
             </a:r>
           </a:p>
           <a:p>
             <a:pPr lvl="2"/>
             <a:r>
-              <a:rPr lang="en-US" smtClean="0"/>
+              <a:rPr lang="en-US"/>
               <a:t>Third level</a:t>
             </a:r>
           </a:p>
           <a:p>
             <a:pPr lvl="3"/>
             <a:r>
-              <a:rPr lang="en-US" smtClean="0"/>
+              <a:rPr lang="en-US"/>
               <a:t>Fourth level</a:t>
             </a:r>
           </a:p>
           <a:p>
             <a:pPr lvl="4"/>
             <a:r>
-              <a:rPr lang="en-US" smtClean="0"/>
+              <a:rPr lang="en-US"/>
               <a:t>Fifth level</a:t>
             </a:r>
-            <a:endParaRPr lang="en-US"/>
           </a:p>
         </p:txBody>
       </p:sp>
@@ -1353,7 +1357,7 @@
           <a:p>
             <a:fld id="{5BCAD085-E8A6-8845-BD4E-CB4CCA059FC4}" type="datetimeFigureOut">
               <a:rPr lang="en-US" smtClean="0"/>
-              <a:t>1/27/13</a:t>
+              <a:t>6/7/2026</a:t>
             </a:fld>
             <a:endParaRPr lang="en-US"/>
           </a:p>
@@ -1395,7 +1399,7 @@
           <a:p>
             <a:fld id="{C1FF6DA9-008F-8B48-92A6-B652298478BF}" type="slidenum">
               <a:rPr lang="en-US" smtClean="0"/>
-              <a:t>‹#›</a:t>
+              <a:t>‹Nº›</a:t>
             </a:fld>
             <a:endParaRPr lang="en-US"/>
           </a:p>
@@ -1451,10 +1455,9 @@
           </a:lstStyle>
           <a:p>
             <a:r>
-              <a:rPr lang="en-US" smtClean="0"/>
+              <a:rPr lang="en-US"/>
               <a:t>Click to edit Master title style</a:t>
             </a:r>
-            <a:endParaRPr lang="en-US"/>
           </a:p>
         </p:txBody>
       </p:sp>
@@ -1517,7 +1520,7 @@
           <a:p>
             <a:pPr lvl="0"/>
             <a:r>
-              <a:rPr lang="en-US" smtClean="0"/>
+              <a:rPr lang="en-US"/>
               <a:t>Click to edit Master text styles</a:t>
             </a:r>
           </a:p>
@@ -1573,38 +1576,37 @@
           <a:p>
             <a:pPr lvl="0"/>
             <a:r>
-              <a:rPr lang="en-US" smtClean="0"/>
+              <a:rPr lang="en-US"/>
               <a:t>Click to edit Master text styles</a:t>
             </a:r>
           </a:p>
           <a:p>
             <a:pPr lvl="1"/>
             <a:r>
-              <a:rPr lang="en-US" smtClean="0"/>
+              <a:rPr lang="en-US"/>
               <a:t>Second level</a:t>
             </a:r>
           </a:p>
           <a:p>
             <a:pPr lvl="2"/>
             <a:r>
-              <a:rPr lang="en-US" smtClean="0"/>
+              <a:rPr lang="en-US"/>
               <a:t>Third level</a:t>
             </a:r>
           </a:p>
           <a:p>
             <a:pPr lvl="3"/>
             <a:r>
-              <a:rPr lang="en-US" smtClean="0"/>
+              <a:rPr lang="en-US"/>
               <a:t>Fourth level</a:t>
             </a:r>
           </a:p>
           <a:p>
             <a:pPr lvl="4"/>
             <a:r>
-              <a:rPr lang="en-US" smtClean="0"/>
+              <a:rPr lang="en-US"/>
               <a:t>Fifth level</a:t>
             </a:r>
-            <a:endParaRPr lang="en-US"/>
           </a:p>
         </p:txBody>
       </p:sp>
@@ -1667,7 +1669,7 @@
           <a:p>
             <a:pPr lvl="0"/>
             <a:r>
-              <a:rPr lang="en-US" smtClean="0"/>
+              <a:rPr lang="en-US"/>
               <a:t>Click to edit Master text styles</a:t>
             </a:r>
           </a:p>
@@ -1723,38 +1725,37 @@
           <a:p>
             <a:pPr lvl="0"/>
             <a:r>
-              <a:rPr lang="en-US" smtClean="0"/>
+              <a:rPr lang="en-US"/>
               <a:t>Click to edit Master text styles</a:t>
             </a:r>
           </a:p>
           <a:p>
             <a:pPr lvl="1"/>
             <a:r>
-              <a:rPr lang="en-US" smtClean="0"/>
+              <a:rPr lang="en-US"/>
               <a:t>Second level</a:t>
             </a:r>
           </a:p>
           <a:p>
             <a:pPr lvl="2"/>
             <a:r>
-              <a:rPr lang="en-US" smtClean="0"/>
+              <a:rPr lang="en-US"/>
               <a:t>Third level</a:t>
             </a:r>
           </a:p>
           <a:p>
             <a:pPr lvl="3"/>
             <a:r>
-              <a:rPr lang="en-US" smtClean="0"/>
+              <a:rPr lang="en-US"/>
               <a:t>Fourth level</a:t>
             </a:r>
           </a:p>
           <a:p>
             <a:pPr lvl="4"/>
             <a:r>
-              <a:rPr lang="en-US" smtClean="0"/>
+              <a:rPr lang="en-US"/>
               <a:t>Fifth level</a:t>
             </a:r>
-            <a:endParaRPr lang="en-US"/>
           </a:p>
         </p:txBody>
       </p:sp>
@@ -1775,7 +1776,7 @@
           <a:p>
             <a:fld id="{5BCAD085-E8A6-8845-BD4E-CB4CCA059FC4}" type="datetimeFigureOut">
               <a:rPr lang="en-US" smtClean="0"/>
-              <a:t>1/27/13</a:t>
+              <a:t>6/7/2026</a:t>
             </a:fld>
             <a:endParaRPr lang="en-US"/>
           </a:p>
@@ -1817,7 +1818,7 @@
           <a:p>
             <a:fld id="{C1FF6DA9-008F-8B48-92A6-B652298478BF}" type="slidenum">
               <a:rPr lang="en-US" smtClean="0"/>
-              <a:t>‹#›</a:t>
+              <a:t>‹Nº›</a:t>
             </a:fld>
             <a:endParaRPr lang="en-US"/>
           </a:p>
@@ -1869,10 +1870,9 @@
           <a:lstStyle/>
           <a:p>
             <a:r>
-              <a:rPr lang="en-US" smtClean="0"/>
+              <a:rPr lang="en-US"/>
               <a:t>Click to edit Master title style</a:t>
             </a:r>
-            <a:endParaRPr lang="en-US"/>
           </a:p>
         </p:txBody>
       </p:sp>
@@ -1893,7 +1893,7 @@
           <a:p>
             <a:fld id="{5BCAD085-E8A6-8845-BD4E-CB4CCA059FC4}" type="datetimeFigureOut">
               <a:rPr lang="en-US" smtClean="0"/>
-              <a:t>1/27/13</a:t>
+              <a:t>6/7/2026</a:t>
             </a:fld>
             <a:endParaRPr lang="en-US"/>
           </a:p>
@@ -1935,7 +1935,7 @@
           <a:p>
             <a:fld id="{C1FF6DA9-008F-8B48-92A6-B652298478BF}" type="slidenum">
               <a:rPr lang="en-US" smtClean="0"/>
-              <a:t>‹#›</a:t>
+              <a:t>‹Nº›</a:t>
             </a:fld>
             <a:endParaRPr lang="en-US"/>
           </a:p>
@@ -1988,7 +1988,7 @@
           <a:p>
             <a:fld id="{5BCAD085-E8A6-8845-BD4E-CB4CCA059FC4}" type="datetimeFigureOut">
               <a:rPr lang="en-US" smtClean="0"/>
-              <a:t>1/27/13</a:t>
+              <a:t>6/7/2026</a:t>
             </a:fld>
             <a:endParaRPr lang="en-US"/>
           </a:p>
@@ -2030,7 +2030,7 @@
           <a:p>
             <a:fld id="{C1FF6DA9-008F-8B48-92A6-B652298478BF}" type="slidenum">
               <a:rPr lang="en-US" smtClean="0"/>
-              <a:t>‹#›</a:t>
+              <a:t>‹Nº›</a:t>
             </a:fld>
             <a:endParaRPr lang="en-US"/>
           </a:p>
@@ -2091,10 +2091,9 @@
           </a:lstStyle>
           <a:p>
             <a:r>
-              <a:rPr lang="en-US" smtClean="0"/>
+              <a:rPr lang="en-US"/>
               <a:t>Click to edit Master title style</a:t>
             </a:r>
-            <a:endParaRPr lang="en-US"/>
           </a:p>
         </p:txBody>
       </p:sp>
@@ -2148,38 +2147,37 @@
           <a:p>
             <a:pPr lvl="0"/>
             <a:r>
-              <a:rPr lang="en-US" smtClean="0"/>
+              <a:rPr lang="en-US"/>
               <a:t>Click to edit Master text styles</a:t>
             </a:r>
           </a:p>
           <a:p>
             <a:pPr lvl="1"/>
             <a:r>
-              <a:rPr lang="en-US" smtClean="0"/>
+              <a:rPr lang="en-US"/>
               <a:t>Second level</a:t>
             </a:r>
           </a:p>
           <a:p>
             <a:pPr lvl="2"/>
             <a:r>
-              <a:rPr lang="en-US" smtClean="0"/>
+              <a:rPr lang="en-US"/>
               <a:t>Third level</a:t>
             </a:r>
           </a:p>
           <a:p>
             <a:pPr lvl="3"/>
             <a:r>
-              <a:rPr lang="en-US" smtClean="0"/>
+              <a:rPr lang="en-US"/>
               <a:t>Fourth level</a:t>
             </a:r>
           </a:p>
           <a:p>
             <a:pPr lvl="4"/>
             <a:r>
-              <a:rPr lang="en-US" smtClean="0"/>
+              <a:rPr lang="en-US"/>
               <a:t>Fifth level</a:t>
             </a:r>
-            <a:endParaRPr lang="en-US"/>
           </a:p>
         </p:txBody>
       </p:sp>
@@ -2242,7 +2240,7 @@
           <a:p>
             <a:pPr lvl="0"/>
             <a:r>
-              <a:rPr lang="en-US" smtClean="0"/>
+              <a:rPr lang="en-US"/>
               <a:t>Click to edit Master text styles</a:t>
             </a:r>
           </a:p>
@@ -2265,7 +2263,7 @@
           <a:p>
             <a:fld id="{5BCAD085-E8A6-8845-BD4E-CB4CCA059FC4}" type="datetimeFigureOut">
               <a:rPr lang="en-US" smtClean="0"/>
-              <a:t>1/27/13</a:t>
+              <a:t>6/7/2026</a:t>
             </a:fld>
             <a:endParaRPr lang="en-US"/>
           </a:p>
@@ -2307,7 +2305,7 @@
           <a:p>
             <a:fld id="{C1FF6DA9-008F-8B48-92A6-B652298478BF}" type="slidenum">
               <a:rPr lang="en-US" smtClean="0"/>
-              <a:t>‹#›</a:t>
+              <a:t>‹Nº›</a:t>
             </a:fld>
             <a:endParaRPr lang="en-US"/>
           </a:p>
@@ -2368,10 +2366,9 @@
           </a:lstStyle>
           <a:p>
             <a:r>
-              <a:rPr lang="en-US" smtClean="0"/>
+              <a:rPr lang="en-US"/>
               <a:t>Click to edit Master title style</a:t>
             </a:r>
-            <a:endParaRPr lang="en-US"/>
           </a:p>
         </p:txBody>
       </p:sp>
@@ -2495,7 +2492,7 @@
           <a:p>
             <a:pPr lvl="0"/>
             <a:r>
-              <a:rPr lang="en-US" smtClean="0"/>
+              <a:rPr lang="en-US"/>
               <a:t>Click to edit Master text styles</a:t>
             </a:r>
           </a:p>
@@ -2518,7 +2515,7 @@
           <a:p>
             <a:fld id="{5BCAD085-E8A6-8845-BD4E-CB4CCA059FC4}" type="datetimeFigureOut">
               <a:rPr lang="en-US" smtClean="0"/>
-              <a:t>1/27/13</a:t>
+              <a:t>6/7/2026</a:t>
             </a:fld>
             <a:endParaRPr lang="en-US"/>
           </a:p>
@@ -2560,7 +2557,7 @@
           <a:p>
             <a:fld id="{C1FF6DA9-008F-8B48-92A6-B652298478BF}" type="slidenum">
               <a:rPr lang="en-US" smtClean="0"/>
-              <a:t>‹#›</a:t>
+              <a:t>‹Nº›</a:t>
             </a:fld>
             <a:endParaRPr lang="en-US"/>
           </a:p>
@@ -2627,10 +2624,9 @@
           <a:lstStyle/>
           <a:p>
             <a:r>
-              <a:rPr lang="en-US" smtClean="0"/>
+              <a:rPr lang="en-US"/>
               <a:t>Click to edit Master title style</a:t>
             </a:r>
-            <a:endParaRPr lang="en-US"/>
           </a:p>
         </p:txBody>
       </p:sp>
@@ -2661,38 +2657,37 @@
           <a:p>
             <a:pPr lvl="0"/>
             <a:r>
-              <a:rPr lang="en-US" smtClean="0"/>
+              <a:rPr lang="en-US"/>
               <a:t>Click to edit Master text styles</a:t>
             </a:r>
           </a:p>
           <a:p>
             <a:pPr lvl="1"/>
             <a:r>
-              <a:rPr lang="en-US" smtClean="0"/>
+              <a:rPr lang="en-US"/>
               <a:t>Second level</a:t>
             </a:r>
           </a:p>
           <a:p>
             <a:pPr lvl="2"/>
             <a:r>
-              <a:rPr lang="en-US" smtClean="0"/>
+              <a:rPr lang="en-US"/>
               <a:t>Third level</a:t>
             </a:r>
           </a:p>
           <a:p>
             <a:pPr lvl="3"/>
             <a:r>
-              <a:rPr lang="en-US" smtClean="0"/>
+              <a:rPr lang="en-US"/>
               <a:t>Fourth level</a:t>
             </a:r>
           </a:p>
           <a:p>
             <a:pPr lvl="4"/>
             <a:r>
-              <a:rPr lang="en-US" smtClean="0"/>
+              <a:rPr lang="en-US"/>
               <a:t>Fifth level</a:t>
             </a:r>
-            <a:endParaRPr lang="en-US"/>
           </a:p>
         </p:txBody>
       </p:sp>
@@ -2731,7 +2726,7 @@
           <a:p>
             <a:fld id="{5BCAD085-E8A6-8845-BD4E-CB4CCA059FC4}" type="datetimeFigureOut">
               <a:rPr lang="en-US" smtClean="0"/>
-              <a:t>1/27/13</a:t>
+              <a:t>6/7/2026</a:t>
             </a:fld>
             <a:endParaRPr lang="en-US"/>
           </a:p>
@@ -2809,7 +2804,7 @@
           <a:p>
             <a:fld id="{C1FF6DA9-008F-8B48-92A6-B652298478BF}" type="slidenum">
               <a:rPr lang="en-US" smtClean="0"/>
-              <a:t>‹#›</a:t>
+              <a:t>‹Nº›</a:t>
             </a:fld>
             <a:endParaRPr lang="en-US"/>
           </a:p>
@@ -3090,7 +3085,7 @@
 </file>
 
 <file path=ppt/slides/slide1.xml><?xml version="1.0" encoding="utf-8"?>
-<p:sld xmlns:a="http://schemas.openxmlformats.org/drawingml/2006/main" xmlns:p="http://schemas.openxmlformats.org/presentationml/2006/main" xmlns:r="http://schemas.openxmlformats.org/officeDocument/2006/relationships">
+<p:sld xmlns:a="http://schemas.openxmlformats.org/drawingml/2006/main" xmlns:r="http://schemas.openxmlformats.org/officeDocument/2006/relationships" xmlns:p="http://schemas.openxmlformats.org/presentationml/2006/main">
   <p:cSld>
     <p:bg>
       <p:bgPr>
@@ -3106,7 +3101,14 @@
         <p:cNvGrpSpPr/>
         <p:nvPr/>
       </p:nvGrpSpPr>
-      <p:grpSpPr/>
+      <p:grpSpPr>
+        <a:xfrm>
+          <a:off x="0" y="0"/>
+          <a:ext cx="0" cy="0"/>
+          <a:chOff x="0" y="0"/>
+          <a:chExt cx="0" cy="0"/>
+        </a:xfrm>
+      </p:grpSpPr>
       <p:sp>
         <p:nvSpPr>
           <p:cNvPr id="2" name="TextBox 1"/>
@@ -3291,7 +3293,7 @@
 </file>
 
 <file path=ppt/slides/slide10.xml><?xml version="1.0" encoding="utf-8"?>
-<p:sld xmlns:a="http://schemas.openxmlformats.org/drawingml/2006/main" xmlns:p="http://schemas.openxmlformats.org/presentationml/2006/main" xmlns:r="http://schemas.openxmlformats.org/officeDocument/2006/relationships">
+<p:sld xmlns:a="http://schemas.openxmlformats.org/drawingml/2006/main" xmlns:r="http://schemas.openxmlformats.org/officeDocument/2006/relationships" xmlns:p="http://schemas.openxmlformats.org/presentationml/2006/main">
   <p:cSld>
     <p:bg>
       <p:bgPr>
@@ -3307,7 +3309,14 @@
         <p:cNvGrpSpPr/>
         <p:nvPr/>
       </p:nvGrpSpPr>
-      <p:grpSpPr/>
+      <p:grpSpPr>
+        <a:xfrm>
+          <a:off x="0" y="0"/>
+          <a:ext cx="0" cy="0"/>
+          <a:chOff x="0" y="0"/>
+          <a:chExt cx="0" cy="0"/>
+        </a:xfrm>
+      </p:grpSpPr>
       <p:sp>
         <p:nvSpPr>
           <p:cNvPr id="2" name="Rectangle 1"/>
@@ -3348,6 +3357,7 @@
           <a:lstStyle/>
           <a:p>
             <a:pPr algn="ctr"/>
+            <a:endParaRPr/>
           </a:p>
         </p:txBody>
       </p:sp>
@@ -3493,7 +3503,7 @@
 </file>
 
 <file path=ppt/slides/slide11.xml><?xml version="1.0" encoding="utf-8"?>
-<p:sld xmlns:a="http://schemas.openxmlformats.org/drawingml/2006/main" xmlns:p="http://schemas.openxmlformats.org/presentationml/2006/main" xmlns:r="http://schemas.openxmlformats.org/officeDocument/2006/relationships">
+<p:sld xmlns:a="http://schemas.openxmlformats.org/drawingml/2006/main" xmlns:r="http://schemas.openxmlformats.org/officeDocument/2006/relationships" xmlns:p="http://schemas.openxmlformats.org/presentationml/2006/main">
   <p:cSld>
     <p:bg>
       <p:bgPr>
@@ -3509,7 +3519,14 @@
         <p:cNvGrpSpPr/>
         <p:nvPr/>
       </p:nvGrpSpPr>
-      <p:grpSpPr/>
+      <p:grpSpPr>
+        <a:xfrm>
+          <a:off x="0" y="0"/>
+          <a:ext cx="0" cy="0"/>
+          <a:chOff x="0" y="0"/>
+          <a:chExt cx="0" cy="0"/>
+        </a:xfrm>
+      </p:grpSpPr>
       <p:sp>
         <p:nvSpPr>
           <p:cNvPr id="2" name="Rectangle 1"/>
@@ -3550,6 +3567,7 @@
           <a:lstStyle/>
           <a:p>
             <a:pPr algn="ctr"/>
+            <a:endParaRPr/>
           </a:p>
         </p:txBody>
       </p:sp>
@@ -3680,7 +3698,7 @@
 </file>
 
 <file path=ppt/slides/slide12.xml><?xml version="1.0" encoding="utf-8"?>
-<p:sld xmlns:a="http://schemas.openxmlformats.org/drawingml/2006/main" xmlns:p="http://schemas.openxmlformats.org/presentationml/2006/main" xmlns:r="http://schemas.openxmlformats.org/officeDocument/2006/relationships">
+<p:sld xmlns:a="http://schemas.openxmlformats.org/drawingml/2006/main" xmlns:r="http://schemas.openxmlformats.org/officeDocument/2006/relationships" xmlns:p="http://schemas.openxmlformats.org/presentationml/2006/main">
   <p:cSld>
     <p:bg>
       <p:bgPr>
@@ -3696,7 +3714,14 @@
         <p:cNvGrpSpPr/>
         <p:nvPr/>
       </p:nvGrpSpPr>
-      <p:grpSpPr/>
+      <p:grpSpPr>
+        <a:xfrm>
+          <a:off x="0" y="0"/>
+          <a:ext cx="0" cy="0"/>
+          <a:chOff x="0" y="0"/>
+          <a:chExt cx="0" cy="0"/>
+        </a:xfrm>
+      </p:grpSpPr>
       <p:sp>
         <p:nvSpPr>
           <p:cNvPr id="2" name="Rectangle 1"/>
@@ -3737,6 +3762,7 @@
           <a:lstStyle/>
           <a:p>
             <a:pPr algn="ctr"/>
+            <a:endParaRPr/>
           </a:p>
         </p:txBody>
       </p:sp>
@@ -3784,7 +3810,7 @@
         <p:spPr>
           <a:xfrm>
             <a:off x="640080" y="1280160"/>
-            <a:ext cx="7863840" cy="5029200"/>
+            <a:ext cx="7863840" cy="1831271"/>
           </a:xfrm>
           <a:prstGeom prst="rect">
             <a:avLst/>
@@ -3808,7 +3834,28 @@
               </a:defRPr>
             </a:pPr>
             <a:r>
-              <a:t>Problema real → solución técnica viable</a:t>
+              <a:rPr dirty="0" err="1"/>
+              <a:t>Problema</a:t>
+            </a:r>
+            <a:r>
+              <a:rPr dirty="0"/>
+              <a:t> real → </a:t>
+            </a:r>
+            <a:r>
+              <a:rPr dirty="0" err="1"/>
+              <a:t>solución</a:t>
+            </a:r>
+            <a:r>
+              <a:rPr dirty="0"/>
+              <a:t> </a:t>
+            </a:r>
+            <a:r>
+              <a:rPr dirty="0" err="1"/>
+              <a:t>técnica</a:t>
+            </a:r>
+            <a:r>
+              <a:rPr dirty="0"/>
+              <a:t> viable</a:t>
             </a:r>
           </a:p>
           <a:p>
@@ -3823,7 +3870,20 @@
               </a:defRPr>
             </a:pPr>
             <a:r>
-              <a:t>Aprendizaje: Android, persistencia, UX</a:t>
+              <a:rPr dirty="0" err="1"/>
+              <a:t>Aprendizaje</a:t>
+            </a:r>
+            <a:r>
+              <a:rPr dirty="0"/>
+              <a:t>: Android, </a:t>
+            </a:r>
+            <a:r>
+              <a:rPr dirty="0" err="1"/>
+              <a:t>persistencia</a:t>
+            </a:r>
+            <a:r>
+              <a:rPr dirty="0"/>
+              <a:t>, UX</a:t>
             </a:r>
           </a:p>
           <a:p>
@@ -3838,7 +3898,12 @@
               </a:defRPr>
             </a:pPr>
             <a:r>
-              <a:t>Agradecimientos a Enric Climent Martí</a:t>
+              <a:rPr dirty="0" err="1"/>
+              <a:t>Agradecimientos</a:t>
+            </a:r>
+            <a:r>
+              <a:rPr dirty="0"/>
+              <a:t> a Enric Climent Martí</a:t>
             </a:r>
           </a:p>
           <a:p>
@@ -3853,7 +3918,15 @@
               </a:defRPr>
             </a:pPr>
             <a:r>
-              <a:t>¿Preguntas del tribunal?</a:t>
+              <a:rPr dirty="0"/>
+              <a:t>¿</a:t>
+            </a:r>
+            <a:r>
+              <a:rPr dirty="0" err="1"/>
+              <a:t>Preguntas</a:t>
+            </a:r>
+            <a:r>
+              <a:t> ?</a:t>
             </a:r>
           </a:p>
         </p:txBody>
@@ -3867,7 +3940,7 @@
 </file>
 
 <file path=ppt/slides/slide2.xml><?xml version="1.0" encoding="utf-8"?>
-<p:sld xmlns:a="http://schemas.openxmlformats.org/drawingml/2006/main" xmlns:p="http://schemas.openxmlformats.org/presentationml/2006/main" xmlns:r="http://schemas.openxmlformats.org/officeDocument/2006/relationships">
+<p:sld xmlns:a="http://schemas.openxmlformats.org/drawingml/2006/main" xmlns:r="http://schemas.openxmlformats.org/officeDocument/2006/relationships" xmlns:p="http://schemas.openxmlformats.org/presentationml/2006/main">
   <p:cSld>
     <p:bg>
       <p:bgPr>
@@ -3883,7 +3956,14 @@
         <p:cNvGrpSpPr/>
         <p:nvPr/>
       </p:nvGrpSpPr>
-      <p:grpSpPr/>
+      <p:grpSpPr>
+        <a:xfrm>
+          <a:off x="0" y="0"/>
+          <a:ext cx="0" cy="0"/>
+          <a:chOff x="0" y="0"/>
+          <a:chExt cx="0" cy="0"/>
+        </a:xfrm>
+      </p:grpSpPr>
       <p:sp>
         <p:nvSpPr>
           <p:cNvPr id="2" name="Rectangle 1"/>
@@ -3924,6 +4004,7 @@
           <a:lstStyle/>
           <a:p>
             <a:pPr algn="ctr"/>
+            <a:endParaRPr/>
           </a:p>
         </p:txBody>
       </p:sp>
@@ -4099,7 +4180,7 @@
 </file>
 
 <file path=ppt/slides/slide3.xml><?xml version="1.0" encoding="utf-8"?>
-<p:sld xmlns:a="http://schemas.openxmlformats.org/drawingml/2006/main" xmlns:p="http://schemas.openxmlformats.org/presentationml/2006/main" xmlns:r="http://schemas.openxmlformats.org/officeDocument/2006/relationships">
+<p:sld xmlns:a="http://schemas.openxmlformats.org/drawingml/2006/main" xmlns:r="http://schemas.openxmlformats.org/officeDocument/2006/relationships" xmlns:p="http://schemas.openxmlformats.org/presentationml/2006/main">
   <p:cSld>
     <p:bg>
       <p:bgPr>
@@ -4115,7 +4196,14 @@
         <p:cNvGrpSpPr/>
         <p:nvPr/>
       </p:nvGrpSpPr>
-      <p:grpSpPr/>
+      <p:grpSpPr>
+        <a:xfrm>
+          <a:off x="0" y="0"/>
+          <a:ext cx="0" cy="0"/>
+          <a:chOff x="0" y="0"/>
+          <a:chExt cx="0" cy="0"/>
+        </a:xfrm>
+      </p:grpSpPr>
       <p:sp>
         <p:nvSpPr>
           <p:cNvPr id="2" name="Rectangle 1"/>
@@ -4156,6 +4244,7 @@
           <a:lstStyle/>
           <a:p>
             <a:pPr algn="ctr"/>
+            <a:endParaRPr/>
           </a:p>
         </p:txBody>
       </p:sp>
@@ -4301,7 +4390,7 @@
 </file>
 
 <file path=ppt/slides/slide4.xml><?xml version="1.0" encoding="utf-8"?>
-<p:sld xmlns:a="http://schemas.openxmlformats.org/drawingml/2006/main" xmlns:p="http://schemas.openxmlformats.org/presentationml/2006/main" xmlns:r="http://schemas.openxmlformats.org/officeDocument/2006/relationships">
+<p:sld xmlns:a="http://schemas.openxmlformats.org/drawingml/2006/main" xmlns:r="http://schemas.openxmlformats.org/officeDocument/2006/relationships" xmlns:p="http://schemas.openxmlformats.org/presentationml/2006/main">
   <p:cSld>
     <p:bg>
       <p:bgPr>
@@ -4317,7 +4406,14 @@
         <p:cNvGrpSpPr/>
         <p:nvPr/>
       </p:nvGrpSpPr>
-      <p:grpSpPr/>
+      <p:grpSpPr>
+        <a:xfrm>
+          <a:off x="0" y="0"/>
+          <a:ext cx="0" cy="0"/>
+          <a:chOff x="0" y="0"/>
+          <a:chExt cx="0" cy="0"/>
+        </a:xfrm>
+      </p:grpSpPr>
       <p:sp>
         <p:nvSpPr>
           <p:cNvPr id="2" name="Rectangle 1"/>
@@ -4358,6 +4454,7 @@
           <a:lstStyle/>
           <a:p>
             <a:pPr algn="ctr"/>
+            <a:endParaRPr/>
           </a:p>
         </p:txBody>
       </p:sp>
@@ -4488,7 +4585,7 @@
 </file>
 
 <file path=ppt/slides/slide5.xml><?xml version="1.0" encoding="utf-8"?>
-<p:sld xmlns:a="http://schemas.openxmlformats.org/drawingml/2006/main" xmlns:p="http://schemas.openxmlformats.org/presentationml/2006/main" xmlns:r="http://schemas.openxmlformats.org/officeDocument/2006/relationships">
+<p:sld xmlns:a="http://schemas.openxmlformats.org/drawingml/2006/main" xmlns:r="http://schemas.openxmlformats.org/officeDocument/2006/relationships" xmlns:p="http://schemas.openxmlformats.org/presentationml/2006/main">
   <p:cSld>
     <p:bg>
       <p:bgPr>
@@ -4504,7 +4601,14 @@
         <p:cNvGrpSpPr/>
         <p:nvPr/>
       </p:nvGrpSpPr>
-      <p:grpSpPr/>
+      <p:grpSpPr>
+        <a:xfrm>
+          <a:off x="0" y="0"/>
+          <a:ext cx="0" cy="0"/>
+          <a:chOff x="0" y="0"/>
+          <a:chExt cx="0" cy="0"/>
+        </a:xfrm>
+      </p:grpSpPr>
       <p:sp>
         <p:nvSpPr>
           <p:cNvPr id="2" name="Rectangle 1"/>
@@ -4545,6 +4649,7 @@
           <a:lstStyle/>
           <a:p>
             <a:pPr algn="ctr"/>
+            <a:endParaRPr/>
           </a:p>
         </p:txBody>
       </p:sp>
@@ -4690,7 +4795,7 @@
 </file>
 
 <file path=ppt/slides/slide6.xml><?xml version="1.0" encoding="utf-8"?>
-<p:sld xmlns:a="http://schemas.openxmlformats.org/drawingml/2006/main" xmlns:p="http://schemas.openxmlformats.org/presentationml/2006/main" xmlns:r="http://schemas.openxmlformats.org/officeDocument/2006/relationships">
+<p:sld xmlns:a="http://schemas.openxmlformats.org/drawingml/2006/main" xmlns:r="http://schemas.openxmlformats.org/officeDocument/2006/relationships" xmlns:p="http://schemas.openxmlformats.org/presentationml/2006/main">
   <p:cSld>
     <p:bg>
       <p:bgPr>
@@ -4706,7 +4811,14 @@
         <p:cNvGrpSpPr/>
         <p:nvPr/>
       </p:nvGrpSpPr>
-      <p:grpSpPr/>
+      <p:grpSpPr>
+        <a:xfrm>
+          <a:off x="0" y="0"/>
+          <a:ext cx="0" cy="0"/>
+          <a:chOff x="0" y="0"/>
+          <a:chExt cx="0" cy="0"/>
+        </a:xfrm>
+      </p:grpSpPr>
       <p:sp>
         <p:nvSpPr>
           <p:cNvPr id="2" name="Rectangle 1"/>
@@ -4747,6 +4859,7 @@
           <a:lstStyle/>
           <a:p>
             <a:pPr algn="ctr"/>
+            <a:endParaRPr/>
           </a:p>
         </p:txBody>
       </p:sp>
@@ -4907,7 +5020,7 @@
 </file>
 
 <file path=ppt/slides/slide7.xml><?xml version="1.0" encoding="utf-8"?>
-<p:sld xmlns:a="http://schemas.openxmlformats.org/drawingml/2006/main" xmlns:p="http://schemas.openxmlformats.org/presentationml/2006/main" xmlns:r="http://schemas.openxmlformats.org/officeDocument/2006/relationships">
+<p:sld xmlns:a="http://schemas.openxmlformats.org/drawingml/2006/main" xmlns:r="http://schemas.openxmlformats.org/officeDocument/2006/relationships" xmlns:p="http://schemas.openxmlformats.org/presentationml/2006/main">
   <p:cSld>
     <p:bg>
       <p:bgPr>
@@ -4923,7 +5036,14 @@
         <p:cNvGrpSpPr/>
         <p:nvPr/>
       </p:nvGrpSpPr>
-      <p:grpSpPr/>
+      <p:grpSpPr>
+        <a:xfrm>
+          <a:off x="0" y="0"/>
+          <a:ext cx="0" cy="0"/>
+          <a:chOff x="0" y="0"/>
+          <a:chExt cx="0" cy="0"/>
+        </a:xfrm>
+      </p:grpSpPr>
       <p:sp>
         <p:nvSpPr>
           <p:cNvPr id="2" name="Rectangle 1"/>
@@ -4964,6 +5084,7 @@
           <a:lstStyle/>
           <a:p>
             <a:pPr algn="ctr"/>
+            <a:endParaRPr/>
           </a:p>
         </p:txBody>
       </p:sp>
@@ -5109,7 +5230,7 @@
 </file>
 
 <file path=ppt/slides/slide8.xml><?xml version="1.0" encoding="utf-8"?>
-<p:sld xmlns:a="http://schemas.openxmlformats.org/drawingml/2006/main" xmlns:p="http://schemas.openxmlformats.org/presentationml/2006/main" xmlns:r="http://schemas.openxmlformats.org/officeDocument/2006/relationships">
+<p:sld xmlns:a="http://schemas.openxmlformats.org/drawingml/2006/main" xmlns:r="http://schemas.openxmlformats.org/officeDocument/2006/relationships" xmlns:p="http://schemas.openxmlformats.org/presentationml/2006/main">
   <p:cSld>
     <p:bg>
       <p:bgPr>
@@ -5125,7 +5246,14 @@
         <p:cNvGrpSpPr/>
         <p:nvPr/>
       </p:nvGrpSpPr>
-      <p:grpSpPr/>
+      <p:grpSpPr>
+        <a:xfrm>
+          <a:off x="0" y="0"/>
+          <a:ext cx="0" cy="0"/>
+          <a:chOff x="0" y="0"/>
+          <a:chExt cx="0" cy="0"/>
+        </a:xfrm>
+      </p:grpSpPr>
       <p:sp>
         <p:nvSpPr>
           <p:cNvPr id="2" name="Rectangle 1"/>
@@ -5166,6 +5294,7 @@
           <a:lstStyle/>
           <a:p>
             <a:pPr algn="ctr"/>
+            <a:endParaRPr/>
           </a:p>
         </p:txBody>
       </p:sp>
@@ -5311,7 +5440,7 @@
 </file>
 
 <file path=ppt/slides/slide9.xml><?xml version="1.0" encoding="utf-8"?>
-<p:sld xmlns:a="http://schemas.openxmlformats.org/drawingml/2006/main" xmlns:p="http://schemas.openxmlformats.org/presentationml/2006/main" xmlns:r="http://schemas.openxmlformats.org/officeDocument/2006/relationships">
+<p:sld xmlns:a="http://schemas.openxmlformats.org/drawingml/2006/main" xmlns:r="http://schemas.openxmlformats.org/officeDocument/2006/relationships" xmlns:p="http://schemas.openxmlformats.org/presentationml/2006/main">
   <p:cSld>
     <p:bg>
       <p:bgPr>
@@ -5327,7 +5456,14 @@
         <p:cNvGrpSpPr/>
         <p:nvPr/>
       </p:nvGrpSpPr>
-      <p:grpSpPr/>
+      <p:grpSpPr>
+        <a:xfrm>
+          <a:off x="0" y="0"/>
+          <a:ext cx="0" cy="0"/>
+          <a:chOff x="0" y="0"/>
+          <a:chExt cx="0" cy="0"/>
+        </a:xfrm>
+      </p:grpSpPr>
       <p:sp>
         <p:nvSpPr>
           <p:cNvPr id="2" name="Rectangle 1"/>
@@ -5368,6 +5504,7 @@
           <a:lstStyle/>
           <a:p>
             <a:pPr algn="ctr"/>
+            <a:endParaRPr/>
           </a:p>
         </p:txBody>
       </p:sp>

</xml_diff>